<commit_message>
Remove unused favicon and update image assets
</commit_message>
<xml_diff>
--- a/public/images/nookly-icon.pptx
+++ b/public/images/nookly-icon.pptx
@@ -112,7 +112,7 @@
             <a:srgbClr val="A4A3A4"/>
           </p15:clr>
         </p15:guide>
-        <p15:guide id="2" pos="3842" userDrawn="1">
+        <p15:guide id="2" pos="3847" userDrawn="1">
           <p15:clr>
             <a:srgbClr val="A4A3A4"/>
           </p15:clr>
@@ -3105,105 +3105,57 @@
       </p:pic>
       <p:grpSp>
         <p:nvGrpSpPr>
-          <p:cNvPr id="20" name="Group 19"/>
+          <p:cNvPr id="45" name="Group 44"/>
           <p:cNvGrpSpPr/>
           <p:nvPr/>
         </p:nvGrpSpPr>
         <p:grpSpPr>
           <a:xfrm>
-            <a:off x="5648960" y="1296035"/>
+            <a:off x="5620385" y="1295400"/>
             <a:ext cx="2029460" cy="2029460"/>
-            <a:chOff x="8896" y="2041"/>
+            <a:chOff x="8851" y="2040"/>
             <a:chExt cx="3196" cy="3196"/>
           </a:xfrm>
         </p:grpSpPr>
-        <p:sp>
-          <p:nvSpPr>
-            <p:cNvPr id="5" name="Rounded Rectangle 4"/>
-            <p:cNvSpPr/>
-            <p:nvPr/>
-          </p:nvSpPr>
-          <p:spPr>
-            <a:xfrm>
-              <a:off x="8896" y="2041"/>
-              <a:ext cx="3197" cy="3197"/>
-            </a:xfrm>
-            <a:prstGeom prst="roundRect">
-              <a:avLst>
-                <a:gd name="adj" fmla="val 27402"/>
-              </a:avLst>
-            </a:prstGeom>
-            <a:solidFill>
-              <a:schemeClr val="accent1">
-                <a:lumMod val="75000"/>
-              </a:schemeClr>
-            </a:solidFill>
-            <a:ln>
-              <a:solidFill>
-                <a:srgbClr val="024AD6"/>
-              </a:solidFill>
-            </a:ln>
-          </p:spPr>
-          <p:style>
-            <a:lnRef idx="0">
-              <a:srgbClr val="FFFFFF"/>
-            </a:lnRef>
-            <a:fillRef idx="1">
-              <a:schemeClr val="accent1"/>
-            </a:fillRef>
-            <a:effectRef idx="0">
-              <a:srgbClr val="FFFFFF"/>
-            </a:effectRef>
-            <a:fontRef idx="minor">
-              <a:schemeClr val="lt1"/>
-            </a:fontRef>
-          </p:style>
-          <p:txBody>
-            <a:bodyPr rtlCol="0" anchor="ctr"/>
-            <a:p>
-              <a:pPr algn="ctr"/>
-              <a:endParaRPr lang="en-US"/>
-            </a:p>
-          </p:txBody>
-        </p:sp>
         <p:grpSp>
           <p:nvGrpSpPr>
-            <p:cNvPr id="19" name="Group 18"/>
+            <p:cNvPr id="20" name="Group 19"/>
             <p:cNvGrpSpPr/>
             <p:nvPr/>
           </p:nvGrpSpPr>
           <p:grpSpPr>
             <a:xfrm>
-              <a:off x="9274" y="2041"/>
-              <a:ext cx="2819" cy="2799"/>
-              <a:chOff x="9274" y="2041"/>
-              <a:chExt cx="2819" cy="2799"/>
+              <a:off x="8851" y="2040"/>
+              <a:ext cx="3197" cy="3197"/>
+              <a:chOff x="8896" y="2041"/>
+              <a:chExt cx="3197" cy="3197"/>
             </a:xfrm>
           </p:grpSpPr>
           <p:sp>
             <p:nvSpPr>
-              <p:cNvPr id="6" name="Diagonal Corners Rounded Rectangle 5"/>
+              <p:cNvPr id="5" name="Rounded Rectangle 4"/>
               <p:cNvSpPr/>
               <p:nvPr/>
             </p:nvSpPr>
             <p:spPr>
               <a:xfrm>
-                <a:off x="9703" y="2041"/>
-                <a:ext cx="2390" cy="2402"/>
+                <a:off x="8896" y="2041"/>
+                <a:ext cx="3197" cy="3197"/>
               </a:xfrm>
-              <a:prstGeom prst="round2DiagRect">
+              <a:prstGeom prst="roundRect">
                 <a:avLst>
-                  <a:gd name="adj1" fmla="val 0"/>
-                  <a:gd name="adj2" fmla="val 32217"/>
+                  <a:gd name="adj" fmla="val 27402"/>
                 </a:avLst>
               </a:prstGeom>
               <a:solidFill>
                 <a:schemeClr val="accent1">
-                  <a:lumMod val="50000"/>
+                  <a:lumMod val="75000"/>
                 </a:schemeClr>
               </a:solidFill>
               <a:ln>
-                <a:noFill/>
+                <a:solidFill>
+                  <a:srgbClr val="024AD6"/>
+                </a:solidFill>
               </a:ln>
             </p:spPr>
             <p:style>
@@ -3230,18 +3182,66 @@
           </p:sp>
           <p:grpSp>
             <p:nvGrpSpPr>
-              <p:cNvPr id="18" name="Group 17"/>
+              <p:cNvPr id="19" name="Group 18"/>
               <p:cNvGrpSpPr/>
               <p:nvPr/>
             </p:nvGrpSpPr>
             <p:grpSpPr>
               <a:xfrm>
-                <a:off x="9274" y="2438"/>
-                <a:ext cx="2568" cy="2402"/>
-                <a:chOff x="9274" y="2438"/>
-                <a:chExt cx="2568" cy="2402"/>
+                <a:off x="9274" y="2041"/>
+                <a:ext cx="2819" cy="2799"/>
+                <a:chOff x="9274" y="2041"/>
+                <a:chExt cx="2819" cy="2799"/>
               </a:xfrm>
             </p:grpSpPr>
+            <p:sp>
+              <p:nvSpPr>
+                <p:cNvPr id="6" name="Diagonal Corners Rounded Rectangle 5"/>
+                <p:cNvSpPr/>
+                <p:nvPr/>
+              </p:nvSpPr>
+              <p:spPr>
+                <a:xfrm>
+                  <a:off x="9703" y="2041"/>
+                  <a:ext cx="2390" cy="2402"/>
+                </a:xfrm>
+                <a:prstGeom prst="round2DiagRect">
+                  <a:avLst>
+                    <a:gd name="adj1" fmla="val 0"/>
+                    <a:gd name="adj2" fmla="val 32217"/>
+                  </a:avLst>
+                </a:prstGeom>
+                <a:solidFill>
+                  <a:schemeClr val="accent1">
+                    <a:lumMod val="50000"/>
+                  </a:schemeClr>
+                </a:solidFill>
+                <a:ln>
+                  <a:noFill/>
+                </a:ln>
+              </p:spPr>
+              <p:style>
+                <a:lnRef idx="0">
+                  <a:srgbClr val="FFFFFF"/>
+                </a:lnRef>
+                <a:fillRef idx="1">
+                  <a:schemeClr val="accent1"/>
+                </a:fillRef>
+                <a:effectRef idx="0">
+                  <a:srgbClr val="FFFFFF"/>
+                </a:effectRef>
+                <a:fontRef idx="minor">
+                  <a:schemeClr val="lt1"/>
+                </a:fontRef>
+              </p:style>
+              <p:txBody>
+                <a:bodyPr rtlCol="0" anchor="ctr"/>
+                <a:p>
+                  <a:pPr algn="ctr"/>
+                  <a:endParaRPr lang="en-US"/>
+                </a:p>
+              </p:txBody>
+            </p:sp>
             <p:sp>
               <p:nvSpPr>
                 <p:cNvPr id="16" name="Diagonal Corners Rounded Rectangle 15"/>
@@ -3288,44 +3288,284 @@
                 </a:p>
               </p:txBody>
             </p:sp>
+          </p:grpSp>
+        </p:grpSp>
+        <p:grpSp>
+          <p:nvGrpSpPr>
+            <p:cNvPr id="44" name="Group 43"/>
+            <p:cNvGrpSpPr/>
+            <p:nvPr/>
+          </p:nvGrpSpPr>
+          <p:grpSpPr>
+            <a:xfrm>
+              <a:off x="9618" y="2173"/>
+              <a:ext cx="2218" cy="2308"/>
+              <a:chOff x="9618" y="2173"/>
+              <a:chExt cx="2218" cy="2308"/>
+            </a:xfrm>
+          </p:grpSpPr>
+          <p:grpSp>
+            <p:nvGrpSpPr>
+              <p:cNvPr id="36" name="Group 35"/>
+              <p:cNvGrpSpPr/>
+              <p:nvPr/>
+            </p:nvGrpSpPr>
+            <p:grpSpPr>
+              <a:xfrm>
+                <a:off x="10689" y="3358"/>
+                <a:ext cx="476" cy="442"/>
+                <a:chOff x="10801" y="3357"/>
+                <a:chExt cx="621" cy="545"/>
+              </a:xfrm>
+            </p:grpSpPr>
+            <p:sp>
+              <p:nvSpPr>
+                <p:cNvPr id="12" name="Rectangle 11"/>
+                <p:cNvSpPr/>
+                <p:nvPr/>
+              </p:nvSpPr>
+              <p:spPr>
+                <a:xfrm>
+                  <a:off x="10801" y="3357"/>
+                  <a:ext cx="294" cy="254"/>
+                </a:xfrm>
+                <a:prstGeom prst="rect">
+                  <a:avLst/>
+                </a:prstGeom>
+                <a:solidFill>
+                  <a:schemeClr val="accent2">
+                    <a:lumMod val="60000"/>
+                    <a:lumOff val="40000"/>
+                  </a:schemeClr>
+                </a:solidFill>
+                <a:ln w="31750"/>
+              </p:spPr>
+              <p:style>
+                <a:lnRef idx="2">
+                  <a:schemeClr val="accent1">
+                    <a:lumMod val="75000"/>
+                  </a:schemeClr>
+                </a:lnRef>
+                <a:fillRef idx="1">
+                  <a:schemeClr val="accent1"/>
+                </a:fillRef>
+                <a:effectRef idx="0">
+                  <a:srgbClr val="FFFFFF"/>
+                </a:effectRef>
+                <a:fontRef idx="minor">
+                  <a:schemeClr val="lt1"/>
+                </a:fontRef>
+              </p:style>
+              <p:txBody>
+                <a:bodyPr rtlCol="0" anchor="ctr"/>
+                <a:p>
+                  <a:pPr algn="ctr"/>
+                  <a:endParaRPr lang="en-US"/>
+                </a:p>
+              </p:txBody>
+            </p:sp>
+            <p:sp>
+              <p:nvSpPr>
+                <p:cNvPr id="21" name="Rectangle 20"/>
+                <p:cNvSpPr/>
+                <p:nvPr/>
+              </p:nvSpPr>
+              <p:spPr>
+                <a:xfrm>
+                  <a:off x="10801" y="3648"/>
+                  <a:ext cx="294" cy="254"/>
+                </a:xfrm>
+                <a:prstGeom prst="rect">
+                  <a:avLst/>
+                </a:prstGeom>
+                <a:solidFill>
+                  <a:schemeClr val="accent2">
+                    <a:lumMod val="60000"/>
+                    <a:lumOff val="40000"/>
+                  </a:schemeClr>
+                </a:solidFill>
+                <a:ln w="31750"/>
+              </p:spPr>
+              <p:style>
+                <a:lnRef idx="2">
+                  <a:schemeClr val="accent1">
+                    <a:lumMod val="75000"/>
+                  </a:schemeClr>
+                </a:lnRef>
+                <a:fillRef idx="1">
+                  <a:schemeClr val="accent1"/>
+                </a:fillRef>
+                <a:effectRef idx="0">
+                  <a:srgbClr val="FFFFFF"/>
+                </a:effectRef>
+                <a:fontRef idx="minor">
+                  <a:schemeClr val="lt1"/>
+                </a:fontRef>
+              </p:style>
+              <p:txBody>
+                <a:bodyPr rtlCol="0" anchor="ctr"/>
+                <a:p>
+                  <a:pPr algn="ctr"/>
+                  <a:endParaRPr lang="en-US"/>
+                </a:p>
+              </p:txBody>
+            </p:sp>
+            <p:sp>
+              <p:nvSpPr>
+                <p:cNvPr id="28" name="Rectangle 27"/>
+                <p:cNvSpPr/>
+                <p:nvPr/>
+              </p:nvSpPr>
+              <p:spPr>
+                <a:xfrm>
+                  <a:off x="11128" y="3357"/>
+                  <a:ext cx="294" cy="254"/>
+                </a:xfrm>
+                <a:prstGeom prst="rect">
+                  <a:avLst/>
+                </a:prstGeom>
+                <a:solidFill>
+                  <a:schemeClr val="accent2">
+                    <a:lumMod val="60000"/>
+                    <a:lumOff val="40000"/>
+                  </a:schemeClr>
+                </a:solidFill>
+                <a:ln w="31750"/>
+              </p:spPr>
+              <p:style>
+                <a:lnRef idx="2">
+                  <a:schemeClr val="accent1">
+                    <a:lumMod val="75000"/>
+                  </a:schemeClr>
+                </a:lnRef>
+                <a:fillRef idx="1">
+                  <a:schemeClr val="accent1"/>
+                </a:fillRef>
+                <a:effectRef idx="0">
+                  <a:srgbClr val="FFFFFF"/>
+                </a:effectRef>
+                <a:fontRef idx="minor">
+                  <a:schemeClr val="lt1"/>
+                </a:fontRef>
+              </p:style>
+              <p:txBody>
+                <a:bodyPr rtlCol="0" anchor="ctr"/>
+                <a:p>
+                  <a:pPr algn="ctr"/>
+                  <a:endParaRPr lang="en-US"/>
+                </a:p>
+              </p:txBody>
+            </p:sp>
+            <p:sp>
+              <p:nvSpPr>
+                <p:cNvPr id="29" name="Rectangle 28"/>
+                <p:cNvSpPr/>
+                <p:nvPr/>
+              </p:nvSpPr>
+              <p:spPr>
+                <a:xfrm>
+                  <a:off x="11128" y="3648"/>
+                  <a:ext cx="294" cy="254"/>
+                </a:xfrm>
+                <a:prstGeom prst="rect">
+                  <a:avLst/>
+                </a:prstGeom>
+                <a:solidFill>
+                  <a:schemeClr val="accent2">
+                    <a:lumMod val="60000"/>
+                    <a:lumOff val="40000"/>
+                  </a:schemeClr>
+                </a:solidFill>
+                <a:ln w="31750"/>
+              </p:spPr>
+              <p:style>
+                <a:lnRef idx="2">
+                  <a:schemeClr val="accent1">
+                    <a:lumMod val="75000"/>
+                  </a:schemeClr>
+                </a:lnRef>
+                <a:fillRef idx="1">
+                  <a:schemeClr val="accent1"/>
+                </a:fillRef>
+                <a:effectRef idx="0">
+                  <a:srgbClr val="FFFFFF"/>
+                </a:effectRef>
+                <a:fontRef idx="minor">
+                  <a:schemeClr val="lt1"/>
+                </a:fontRef>
+              </p:style>
+              <p:txBody>
+                <a:bodyPr rtlCol="0" anchor="ctr"/>
+                <a:p>
+                  <a:pPr algn="ctr"/>
+                  <a:endParaRPr lang="en-US"/>
+                </a:p>
+              </p:txBody>
+            </p:sp>
+          </p:grpSp>
+          <p:grpSp>
+            <p:nvGrpSpPr>
+              <p:cNvPr id="43" name="Group 42"/>
+              <p:cNvGrpSpPr/>
+              <p:nvPr/>
+            </p:nvGrpSpPr>
+            <p:grpSpPr>
+              <a:xfrm>
+                <a:off x="9618" y="2173"/>
+                <a:ext cx="2218" cy="2308"/>
+                <a:chOff x="9618" y="2173"/>
+                <a:chExt cx="2218" cy="2308"/>
+              </a:xfrm>
+            </p:grpSpPr>
             <p:grpSp>
               <p:nvGrpSpPr>
-                <p:cNvPr id="17" name="Group 16"/>
+                <p:cNvPr id="37" name="Group 36"/>
                 <p:cNvGrpSpPr/>
                 <p:nvPr/>
               </p:nvGrpSpPr>
               <p:grpSpPr>
                 <a:xfrm>
-                  <a:off x="9604" y="2753"/>
-                  <a:ext cx="1948" cy="1690"/>
-                  <a:chOff x="9604" y="2753"/>
-                  <a:chExt cx="1948" cy="1690"/>
+                  <a:off x="10215" y="3099"/>
+                  <a:ext cx="224" cy="1383"/>
+                  <a:chOff x="10240" y="3038"/>
+                  <a:chExt cx="224" cy="1402"/>
                 </a:xfrm>
               </p:grpSpPr>
               <p:sp>
                 <p:nvSpPr>
-                  <p:cNvPr id="11" name="Rectangle 10"/>
+                  <p:cNvPr id="23" name="Diagonal Corners Snipped Rectangle 22"/>
                   <p:cNvSpPr/>
                   <p:nvPr/>
                 </p:nvSpPr>
                 <p:spPr>
-                  <a:xfrm>
-                    <a:off x="9604" y="2753"/>
-                    <a:ext cx="528" cy="1690"/>
+                  <a:xfrm flipH="1">
+                    <a:off x="10240" y="3038"/>
+                    <a:ext cx="225" cy="1403"/>
                   </a:xfrm>
-                  <a:prstGeom prst="rect">
-                    <a:avLst/>
+                  <a:prstGeom prst="snip2DiagRect">
+                    <a:avLst>
+                      <a:gd name="adj1" fmla="val 2222"/>
+                      <a:gd name="adj2" fmla="val 50000"/>
+                    </a:avLst>
                   </a:prstGeom>
                   <a:solidFill>
-                    <a:srgbClr val="FE8300"/>
+                    <a:schemeClr val="accent2">
+                      <a:lumMod val="75000"/>
+                    </a:schemeClr>
                   </a:solidFill>
                   <a:ln>
-                    <a:noFill/>
+                    <a:solidFill>
+                      <a:schemeClr val="accent2">
+                        <a:lumMod val="75000"/>
+                      </a:schemeClr>
+                    </a:solidFill>
                   </a:ln>
                 </p:spPr>
                 <p:style>
-                  <a:lnRef idx="0">
-                    <a:srgbClr val="FFFFFF"/>
+                  <a:lnRef idx="2">
+                    <a:schemeClr val="accent1">
+                      <a:lumMod val="75000"/>
+                    </a:schemeClr>
                   </a:lnRef>
                   <a:fillRef idx="1">
                     <a:schemeClr val="accent1"/>
@@ -3347,28 +3587,96 @@
               </p:sp>
               <p:sp>
                 <p:nvSpPr>
-                  <p:cNvPr id="13" name="Rectangle 12"/>
+                  <p:cNvPr id="24" name="Oval 23"/>
                   <p:cNvSpPr/>
                   <p:nvPr/>
                 </p:nvSpPr>
                 <p:spPr>
                   <a:xfrm>
-                    <a:off x="11024" y="2753"/>
-                    <a:ext cx="528" cy="1690"/>
+                    <a:off x="10283" y="3568"/>
+                    <a:ext cx="140" cy="140"/>
                   </a:xfrm>
-                  <a:prstGeom prst="rect">
+                  <a:prstGeom prst="ellipse">
                     <a:avLst/>
                   </a:prstGeom>
                   <a:solidFill>
-                    <a:srgbClr val="FE8300"/>
+                    <a:srgbClr val="F66234"/>
+                  </a:solidFill>
+                  <a:ln w="28575">
+                    <a:solidFill>
+                      <a:schemeClr val="accent2">
+                        <a:lumMod val="50000"/>
+                      </a:schemeClr>
+                    </a:solidFill>
+                  </a:ln>
+                </p:spPr>
+                <p:style>
+                  <a:lnRef idx="2">
+                    <a:schemeClr val="accent1">
+                      <a:lumMod val="75000"/>
+                    </a:schemeClr>
+                  </a:lnRef>
+                  <a:fillRef idx="1">
+                    <a:schemeClr val="accent1"/>
+                  </a:fillRef>
+                  <a:effectRef idx="0">
+                    <a:srgbClr val="FFFFFF"/>
+                  </a:effectRef>
+                  <a:fontRef idx="minor">
+                    <a:schemeClr val="lt1"/>
+                  </a:fontRef>
+                </p:style>
+                <p:txBody>
+                  <a:bodyPr rtlCol="0" anchor="ctr"/>
+                  <a:p>
+                    <a:pPr algn="ctr"/>
+                    <a:endParaRPr lang="en-US"/>
+                  </a:p>
+                </p:txBody>
+              </p:sp>
+            </p:grpSp>
+            <p:grpSp>
+              <p:nvGrpSpPr>
+                <p:cNvPr id="39" name="Group 38"/>
+                <p:cNvGrpSpPr/>
+                <p:nvPr/>
+              </p:nvGrpSpPr>
+              <p:grpSpPr>
+                <a:xfrm>
+                  <a:off x="9618" y="2173"/>
+                  <a:ext cx="2219" cy="2308"/>
+                  <a:chOff x="9618" y="2173"/>
+                  <a:chExt cx="2219" cy="2308"/>
+                </a:xfrm>
+              </p:grpSpPr>
+              <p:sp>
+                <p:nvSpPr>
+                  <p:cNvPr id="33" name="Rounded Rectangle 32"/>
+                  <p:cNvSpPr/>
+                  <p:nvPr/>
+                </p:nvSpPr>
+                <p:spPr>
+                  <a:xfrm rot="18780000">
+                    <a:off x="9234" y="2784"/>
+                    <a:ext cx="1413" cy="190"/>
+                  </a:xfrm>
+                  <a:prstGeom prst="roundRect">
+                    <a:avLst/>
+                  </a:prstGeom>
+                  <a:solidFill>
+                    <a:schemeClr val="accent2">
+                      <a:lumMod val="75000"/>
+                    </a:schemeClr>
                   </a:solidFill>
                   <a:ln>
                     <a:noFill/>
                   </a:ln>
                 </p:spPr>
                 <p:style>
-                  <a:lnRef idx="0">
-                    <a:srgbClr val="FFFFFF"/>
+                  <a:lnRef idx="2">
+                    <a:schemeClr val="accent1">
+                      <a:lumMod val="75000"/>
+                    </a:schemeClr>
                   </a:lnRef>
                   <a:fillRef idx="1">
                     <a:schemeClr val="accent1"/>
@@ -3390,23 +3698,71 @@
               </p:sp>
               <p:sp>
                 <p:nvSpPr>
-                  <p:cNvPr id="14" name="Diagonal Corners Snipped Rectangle 13"/>
+                  <p:cNvPr id="34" name="Rounded Rectangle 33"/>
                   <p:cNvSpPr/>
                   <p:nvPr/>
                 </p:nvSpPr>
                 <p:spPr>
-                  <a:xfrm>
-                    <a:off x="10353" y="2988"/>
-                    <a:ext cx="451" cy="1220"/>
+                  <a:xfrm rot="2160000">
+                    <a:off x="10133" y="2788"/>
+                    <a:ext cx="1705" cy="190"/>
                   </a:xfrm>
-                  <a:prstGeom prst="snip2DiagRect">
+                  <a:prstGeom prst="roundRect">
+                    <a:avLst/>
+                  </a:prstGeom>
+                  <a:solidFill>
+                    <a:schemeClr val="accent2">
+                      <a:lumMod val="75000"/>
+                    </a:schemeClr>
+                  </a:solidFill>
+                  <a:ln>
+                    <a:noFill/>
+                  </a:ln>
+                </p:spPr>
+                <p:style>
+                  <a:lnRef idx="2">
+                    <a:schemeClr val="accent1">
+                      <a:lumMod val="75000"/>
+                    </a:schemeClr>
+                  </a:lnRef>
+                  <a:fillRef idx="1">
+                    <a:schemeClr val="accent1"/>
+                  </a:fillRef>
+                  <a:effectRef idx="0">
+                    <a:srgbClr val="FFFFFF"/>
+                  </a:effectRef>
+                  <a:fontRef idx="minor">
+                    <a:schemeClr val="lt1"/>
+                  </a:fontRef>
+                </p:style>
+                <p:txBody>
+                  <a:bodyPr rtlCol="0" anchor="ctr"/>
+                  <a:p>
+                    <a:pPr algn="ctr"/>
+                    <a:endParaRPr lang="en-US"/>
+                  </a:p>
+                </p:txBody>
+              </p:sp>
+              <p:sp>
+                <p:nvSpPr>
+                  <p:cNvPr id="38" name="Round Single Corner Rectangle 37"/>
+                  <p:cNvSpPr/>
+                  <p:nvPr/>
+                </p:nvSpPr>
+                <p:spPr>
+                  <a:xfrm rot="10800000">
+                    <a:off x="9618" y="3159"/>
+                    <a:ext cx="138" cy="1323"/>
+                  </a:xfrm>
+                  <a:prstGeom prst="round1Rect">
                     <a:avLst>
-                      <a:gd name="adj1" fmla="val 0"/>
-                      <a:gd name="adj2" fmla="val 50000"/>
+                      <a:gd name="adj" fmla="val 50000"/>
                     </a:avLst>
                   </a:prstGeom>
                   <a:solidFill>
-                    <a:srgbClr val="FE8300"/>
+                    <a:schemeClr val="accent2">
+                      <a:lumMod val="75000"/>
+                    </a:schemeClr>
                   </a:solidFill>
                   <a:ln>
                     <a:noFill/>

</xml_diff>